<commit_message>
carrusel-01 v2: fix portada title, dual card, escalera spacing
</commit_message>
<xml_diff>
--- a/carrusel-01.pptx
+++ b/carrusel-01.pptx
@@ -2001,8 +2001,8 @@
         </p:nvSpPr>
         <p:spPr>
           <a:xfrm>
-            <a:off x="685800" y="9315450"/>
-            <a:ext cx="8915400" cy="2476500"/>
+            <a:off x="685800" y="9239250"/>
+            <a:ext cx="8915400" cy="2667000"/>
           </a:xfrm>
           <a:prstGeom prst="rect">
             <a:avLst/>
@@ -2021,7 +2021,7 @@
               <a:buNone/>
             </a:pPr>
             <a:r>
-              <a:rPr lang="en-US" sz="7200" b="1" spc="-300" kern="0" dirty="0">
+              <a:rPr lang="en-US" sz="5400" b="1" spc="-300" kern="0" dirty="0">
                 <a:solidFill>
                   <a:srgbClr val="FFFFFF"/>
                 </a:solidFill>
@@ -2031,7 +2031,7 @@
               </a:rPr>
               <a:t>LA IA YA TOMA DECISIONES. ¿QUIÉN LAS REVISA?</a:t>
             </a:r>
-            <a:endParaRPr lang="en-US" sz="7200" dirty="0"/>
+            <a:endParaRPr lang="en-US" sz="5400" dirty="0"/>
           </a:p>
         </p:txBody>
       </p:sp>
@@ -2327,7 +2327,7 @@
               <a:buNone/>
             </a:pPr>
             <a:r>
-              <a:rPr lang="en-US" sz="3600" b="1" spc="2000" kern="0" dirty="0">
+              <a:rPr lang="en-US" sz="3600" b="1" spc="400" kern="0" dirty="0">
                 <a:solidFill>
                   <a:srgbClr val="FFFFFF"/>
                 </a:solidFill>
@@ -2429,7 +2429,7 @@
               <a:buNone/>
             </a:pPr>
             <a:r>
-              <a:rPr lang="en-US" sz="3600" b="1" spc="2000" kern="0" dirty="0">
+              <a:rPr lang="en-US" sz="3600" b="1" spc="400" kern="0" dirty="0">
                 <a:solidFill>
                   <a:srgbClr val="FFFFFF"/>
                 </a:solidFill>
@@ -2531,7 +2531,7 @@
               <a:buNone/>
             </a:pPr>
             <a:r>
-              <a:rPr lang="en-US" sz="3600" b="1" spc="2000" kern="0" dirty="0">
+              <a:rPr lang="en-US" sz="3600" b="1" spc="400" kern="0" dirty="0">
                 <a:solidFill>
                   <a:srgbClr val="FFFFFF"/>
                 </a:solidFill>
@@ -2633,7 +2633,7 @@
               <a:buNone/>
             </a:pPr>
             <a:r>
-              <a:rPr lang="en-US" sz="3600" b="1" spc="2000" kern="0" dirty="0">
+              <a:rPr lang="en-US" sz="3600" b="1" spc="400" kern="0" dirty="0">
                 <a:solidFill>
                   <a:srgbClr val="FFFFFF"/>
                 </a:solidFill>
@@ -3918,6 +3918,26 @@
               <a:buNone/>
             </a:pPr>
             <a:r>
+              <a:rPr lang="en-US" sz="2300" b="1" spc="500" kern="0" dirty="0">
+                <a:solidFill>
+                  <a:srgbClr val="FFFFFF"/>
+                </a:solidFill>
+                <a:latin typeface="TT Hoves Pro" pitchFamily="34" charset="0"/>
+                <a:ea typeface="TT Hoves Pro" pitchFamily="34" charset="-122"/>
+                <a:cs typeface="TT Hoves Pro" pitchFamily="34" charset="-120"/>
+              </a:rPr>
+              <a:t> </a:t>
+            </a:r>
+            <a:endParaRPr lang="en-US" sz="4600" dirty="0"/>
+          </a:p>
+          <a:p>
+            <a:pPr algn="ctr" indent="0" marL="0">
+              <a:lnSpc>
+                <a:spcPct val="135000"/>
+              </a:lnSpc>
+              <a:buNone/>
+            </a:pPr>
+            <a:r>
               <a:rPr lang="en-US" sz="3200" b="1" spc="500" kern="0" dirty="0">
                 <a:solidFill>
                   <a:srgbClr val="C8BAEF"/>
@@ -4203,7 +4223,7 @@
               <a:buNone/>
             </a:pPr>
             <a:r>
-              <a:rPr lang="en-US" sz="2800" b="1" spc="4500" kern="0" dirty="0">
+              <a:rPr lang="en-US" sz="2400" b="1" spc="2000" kern="0" dirty="0">
                 <a:solidFill>
                   <a:srgbClr val="9275E5"/>
                 </a:solidFill>
@@ -4213,7 +4233,7 @@
               </a:rPr>
               <a:t>TÉCNICO</a:t>
             </a:r>
-            <a:endParaRPr lang="en-US" sz="2800" dirty="0"/>
+            <a:endParaRPr lang="en-US" sz="2400" dirty="0"/>
           </a:p>
         </p:txBody>
       </p:sp>
@@ -4326,7 +4346,7 @@
               <a:buNone/>
             </a:pPr>
             <a:r>
-              <a:rPr lang="en-US" sz="2800" b="1" spc="4500" kern="0" dirty="0">
+              <a:rPr lang="en-US" sz="2400" b="1" spc="2000" kern="0" dirty="0">
                 <a:solidFill>
                   <a:srgbClr val="9275E5"/>
                 </a:solidFill>
@@ -4336,7 +4356,7 @@
               </a:rPr>
               <a:t>GOBERNANZA</a:t>
             </a:r>
-            <a:endParaRPr lang="en-US" sz="2800" dirty="0"/>
+            <a:endParaRPr lang="en-US" sz="2400" dirty="0"/>
           </a:p>
         </p:txBody>
       </p:sp>
@@ -4577,6 +4597,26 @@
               </a:rPr>
               <a:t> EN AI SAFETY TÉCNICO Y EN GOBERNANZA EN IA. NO NECESITÁS EXPERIENCIA PREVIA PARA EMPEZAR.</a:t>
             </a:r>
+            <a:pPr algn="ctr" indent="0" marL="0">
+              <a:lnSpc>
+                <a:spcPct val="135000"/>
+              </a:lnSpc>
+              <a:buNone/>
+            </a:pPr>
+            <a:r>
+              <a:rPr lang="en-US" sz="2300" b="1" spc="500" kern="0" dirty="0">
+                <a:solidFill>
+                  <a:srgbClr val="1A1A1E"/>
+                </a:solidFill>
+                <a:latin typeface="TT Hoves Pro" pitchFamily="34" charset="0"/>
+                <a:ea typeface="TT Hoves Pro" pitchFamily="34" charset="-122"/>
+                <a:cs typeface="TT Hoves Pro" pitchFamily="34" charset="-120"/>
+              </a:rPr>
+              <a:t> </a:t>
+            </a:r>
+            <a:endParaRPr lang="en-US" sz="4600" dirty="0"/>
+          </a:p>
+          <a:p>
             <a:pPr algn="ctr" indent="0" marL="0">
               <a:lnSpc>
                 <a:spcPct val="135000"/>

</xml_diff>